<commit_message>
BIG CHANGE restricting >10 GPS
</commit_message>
<xml_diff>
--- a/figures/edit_plots.pptx
+++ b/figures/edit_plots.pptx
@@ -259,7 +259,7 @@
           <a:p>
             <a:fld id="{D5E57551-51E6-461E-8289-1C3752ED2C25}" type="datetimeFigureOut">
               <a:rPr lang="en-US" smtClean="0"/>
-              <a:t>4/15/2026</a:t>
+              <a:t>4/18/2026</a:t>
             </a:fld>
             <a:endParaRPr lang="en-US"/>
           </a:p>
@@ -457,7 +457,7 @@
           <a:p>
             <a:fld id="{D5E57551-51E6-461E-8289-1C3752ED2C25}" type="datetimeFigureOut">
               <a:rPr lang="en-US" smtClean="0"/>
-              <a:t>4/15/2026</a:t>
+              <a:t>4/18/2026</a:t>
             </a:fld>
             <a:endParaRPr lang="en-US"/>
           </a:p>
@@ -665,7 +665,7 @@
           <a:p>
             <a:fld id="{D5E57551-51E6-461E-8289-1C3752ED2C25}" type="datetimeFigureOut">
               <a:rPr lang="en-US" smtClean="0"/>
-              <a:t>4/15/2026</a:t>
+              <a:t>4/18/2026</a:t>
             </a:fld>
             <a:endParaRPr lang="en-US"/>
           </a:p>
@@ -863,7 +863,7 @@
           <a:p>
             <a:fld id="{D5E57551-51E6-461E-8289-1C3752ED2C25}" type="datetimeFigureOut">
               <a:rPr lang="en-US" smtClean="0"/>
-              <a:t>4/15/2026</a:t>
+              <a:t>4/18/2026</a:t>
             </a:fld>
             <a:endParaRPr lang="en-US"/>
           </a:p>
@@ -1138,7 +1138,7 @@
           <a:p>
             <a:fld id="{D5E57551-51E6-461E-8289-1C3752ED2C25}" type="datetimeFigureOut">
               <a:rPr lang="en-US" smtClean="0"/>
-              <a:t>4/15/2026</a:t>
+              <a:t>4/18/2026</a:t>
             </a:fld>
             <a:endParaRPr lang="en-US"/>
           </a:p>
@@ -1403,7 +1403,7 @@
           <a:p>
             <a:fld id="{D5E57551-51E6-461E-8289-1C3752ED2C25}" type="datetimeFigureOut">
               <a:rPr lang="en-US" smtClean="0"/>
-              <a:t>4/15/2026</a:t>
+              <a:t>4/18/2026</a:t>
             </a:fld>
             <a:endParaRPr lang="en-US"/>
           </a:p>
@@ -1815,7 +1815,7 @@
           <a:p>
             <a:fld id="{D5E57551-51E6-461E-8289-1C3752ED2C25}" type="datetimeFigureOut">
               <a:rPr lang="en-US" smtClean="0"/>
-              <a:t>4/15/2026</a:t>
+              <a:t>4/18/2026</a:t>
             </a:fld>
             <a:endParaRPr lang="en-US"/>
           </a:p>
@@ -1956,7 +1956,7 @@
           <a:p>
             <a:fld id="{D5E57551-51E6-461E-8289-1C3752ED2C25}" type="datetimeFigureOut">
               <a:rPr lang="en-US" smtClean="0"/>
-              <a:t>4/15/2026</a:t>
+              <a:t>4/18/2026</a:t>
             </a:fld>
             <a:endParaRPr lang="en-US"/>
           </a:p>
@@ -2069,7 +2069,7 @@
           <a:p>
             <a:fld id="{D5E57551-51E6-461E-8289-1C3752ED2C25}" type="datetimeFigureOut">
               <a:rPr lang="en-US" smtClean="0"/>
-              <a:t>4/15/2026</a:t>
+              <a:t>4/18/2026</a:t>
             </a:fld>
             <a:endParaRPr lang="en-US"/>
           </a:p>
@@ -2380,7 +2380,7 @@
           <a:p>
             <a:fld id="{D5E57551-51E6-461E-8289-1C3752ED2C25}" type="datetimeFigureOut">
               <a:rPr lang="en-US" smtClean="0"/>
-              <a:t>4/15/2026</a:t>
+              <a:t>4/18/2026</a:t>
             </a:fld>
             <a:endParaRPr lang="en-US"/>
           </a:p>
@@ -2668,7 +2668,7 @@
           <a:p>
             <a:fld id="{D5E57551-51E6-461E-8289-1C3752ED2C25}" type="datetimeFigureOut">
               <a:rPr lang="en-US" smtClean="0"/>
-              <a:t>4/15/2026</a:t>
+              <a:t>4/18/2026</a:t>
             </a:fld>
             <a:endParaRPr lang="en-US"/>
           </a:p>
@@ -2909,7 +2909,7 @@
           <a:p>
             <a:fld id="{D5E57551-51E6-461E-8289-1C3752ED2C25}" type="datetimeFigureOut">
               <a:rPr lang="en-US" smtClean="0"/>
-              <a:t>4/15/2026</a:t>
+              <a:t>4/18/2026</a:t>
             </a:fld>
             <a:endParaRPr lang="en-US"/>
           </a:p>
@@ -3331,7 +3331,7 @@
           <p:cNvPr id="4" name="Graphic 3">
             <a:extLst>
               <a:ext uri="{FF2B5EF4-FFF2-40B4-BE49-F238E27FC236}">
-                <a16:creationId xmlns:a16="http://schemas.microsoft.com/office/drawing/2014/main" id="{FD61C34C-99BE-C8E2-D8E0-F6990EA3264B}"/>
+                <a16:creationId xmlns:a16="http://schemas.microsoft.com/office/drawing/2014/main" id="{6A2EB6E3-DD57-F8E9-0A3F-26A055D994E8}"/>
               </a:ext>
             </a:extLst>
           </p:cNvPr>
@@ -3348,15 +3348,15 @@
               </a:ext>
             </a:extLst>
           </a:blip>
-          <a:srcRect t="6781"/>
+          <a:srcRect l="575" t="8285"/>
           <a:stretch>
             <a:fillRect/>
           </a:stretch>
         </p:blipFill>
         <p:spPr>
           <a:xfrm>
-            <a:off x="0" y="0"/>
-            <a:ext cx="6400800" cy="5114376"/>
+            <a:off x="18790" y="206679"/>
+            <a:ext cx="6246606" cy="4939012"/>
           </a:xfrm>
           <a:prstGeom prst="rect">
             <a:avLst/>
@@ -3365,10 +3365,10 @@
       </p:pic>
       <p:pic>
         <p:nvPicPr>
-          <p:cNvPr id="7" name="Graphic 6">
-            <a:extLst>
-              <a:ext uri="{FF2B5EF4-FFF2-40B4-BE49-F238E27FC236}">
-                <a16:creationId xmlns:a16="http://schemas.microsoft.com/office/drawing/2014/main" id="{E75B1507-DBC1-8A7B-164D-F2CC9B4956D5}"/>
+          <p:cNvPr id="10" name="Graphic 9">
+            <a:extLst>
+              <a:ext uri="{FF2B5EF4-FFF2-40B4-BE49-F238E27FC236}">
+                <a16:creationId xmlns:a16="http://schemas.microsoft.com/office/drawing/2014/main" id="{E49B80EC-8E94-D744-98C3-2089F98A0D24}"/>
               </a:ext>
             </a:extLst>
           </p:cNvPr>
@@ -3385,15 +3385,15 @@
               </a:ext>
             </a:extLst>
           </a:blip>
-          <a:srcRect r="13974"/>
+          <a:srcRect r="13003"/>
           <a:stretch>
             <a:fillRect/>
           </a:stretch>
         </p:blipFill>
         <p:spPr>
           <a:xfrm>
-            <a:off x="6375789" y="82544"/>
-            <a:ext cx="5771607" cy="5031832"/>
+            <a:off x="6265396" y="5056"/>
+            <a:ext cx="5926604" cy="5109320"/>
           </a:xfrm>
           <a:prstGeom prst="rect">
             <a:avLst/>

</xml_diff>

<commit_message>
added prediction plot for kill availability model
</commit_message>
<xml_diff>
--- a/figures/edit_plots.pptx
+++ b/figures/edit_plots.pptx
@@ -6,6 +6,7 @@
   </p:sldMasterIdLst>
   <p:sldIdLst>
     <p:sldId id="256" r:id="rId2"/>
+    <p:sldId id="257" r:id="rId3"/>
   </p:sldIdLst>
   <p:sldSz cx="12192000" cy="6858000"/>
   <p:notesSz cx="6858000" cy="9144000"/>
@@ -259,7 +260,7 @@
           <a:p>
             <a:fld id="{D5E57551-51E6-461E-8289-1C3752ED2C25}" type="datetimeFigureOut">
               <a:rPr lang="en-US" smtClean="0"/>
-              <a:t>4/18/2026</a:t>
+              <a:t>4/21/2026</a:t>
             </a:fld>
             <a:endParaRPr lang="en-US"/>
           </a:p>
@@ -457,7 +458,7 @@
           <a:p>
             <a:fld id="{D5E57551-51E6-461E-8289-1C3752ED2C25}" type="datetimeFigureOut">
               <a:rPr lang="en-US" smtClean="0"/>
-              <a:t>4/18/2026</a:t>
+              <a:t>4/21/2026</a:t>
             </a:fld>
             <a:endParaRPr lang="en-US"/>
           </a:p>
@@ -665,7 +666,7 @@
           <a:p>
             <a:fld id="{D5E57551-51E6-461E-8289-1C3752ED2C25}" type="datetimeFigureOut">
               <a:rPr lang="en-US" smtClean="0"/>
-              <a:t>4/18/2026</a:t>
+              <a:t>4/21/2026</a:t>
             </a:fld>
             <a:endParaRPr lang="en-US"/>
           </a:p>
@@ -863,7 +864,7 @@
           <a:p>
             <a:fld id="{D5E57551-51E6-461E-8289-1C3752ED2C25}" type="datetimeFigureOut">
               <a:rPr lang="en-US" smtClean="0"/>
-              <a:t>4/18/2026</a:t>
+              <a:t>4/21/2026</a:t>
             </a:fld>
             <a:endParaRPr lang="en-US"/>
           </a:p>
@@ -1138,7 +1139,7 @@
           <a:p>
             <a:fld id="{D5E57551-51E6-461E-8289-1C3752ED2C25}" type="datetimeFigureOut">
               <a:rPr lang="en-US" smtClean="0"/>
-              <a:t>4/18/2026</a:t>
+              <a:t>4/21/2026</a:t>
             </a:fld>
             <a:endParaRPr lang="en-US"/>
           </a:p>
@@ -1403,7 +1404,7 @@
           <a:p>
             <a:fld id="{D5E57551-51E6-461E-8289-1C3752ED2C25}" type="datetimeFigureOut">
               <a:rPr lang="en-US" smtClean="0"/>
-              <a:t>4/18/2026</a:t>
+              <a:t>4/21/2026</a:t>
             </a:fld>
             <a:endParaRPr lang="en-US"/>
           </a:p>
@@ -1815,7 +1816,7 @@
           <a:p>
             <a:fld id="{D5E57551-51E6-461E-8289-1C3752ED2C25}" type="datetimeFigureOut">
               <a:rPr lang="en-US" smtClean="0"/>
-              <a:t>4/18/2026</a:t>
+              <a:t>4/21/2026</a:t>
             </a:fld>
             <a:endParaRPr lang="en-US"/>
           </a:p>
@@ -1956,7 +1957,7 @@
           <a:p>
             <a:fld id="{D5E57551-51E6-461E-8289-1C3752ED2C25}" type="datetimeFigureOut">
               <a:rPr lang="en-US" smtClean="0"/>
-              <a:t>4/18/2026</a:t>
+              <a:t>4/21/2026</a:t>
             </a:fld>
             <a:endParaRPr lang="en-US"/>
           </a:p>
@@ -2069,7 +2070,7 @@
           <a:p>
             <a:fld id="{D5E57551-51E6-461E-8289-1C3752ED2C25}" type="datetimeFigureOut">
               <a:rPr lang="en-US" smtClean="0"/>
-              <a:t>4/18/2026</a:t>
+              <a:t>4/21/2026</a:t>
             </a:fld>
             <a:endParaRPr lang="en-US"/>
           </a:p>
@@ -2380,7 +2381,7 @@
           <a:p>
             <a:fld id="{D5E57551-51E6-461E-8289-1C3752ED2C25}" type="datetimeFigureOut">
               <a:rPr lang="en-US" smtClean="0"/>
-              <a:t>4/18/2026</a:t>
+              <a:t>4/21/2026</a:t>
             </a:fld>
             <a:endParaRPr lang="en-US"/>
           </a:p>
@@ -2668,7 +2669,7 @@
           <a:p>
             <a:fld id="{D5E57551-51E6-461E-8289-1C3752ED2C25}" type="datetimeFigureOut">
               <a:rPr lang="en-US" smtClean="0"/>
-              <a:t>4/18/2026</a:t>
+              <a:t>4/21/2026</a:t>
             </a:fld>
             <a:endParaRPr lang="en-US"/>
           </a:p>
@@ -2909,7 +2910,7 @@
           <a:p>
             <a:fld id="{D5E57551-51E6-461E-8289-1C3752ED2C25}" type="datetimeFigureOut">
               <a:rPr lang="en-US" smtClean="0"/>
-              <a:t>4/18/2026</a:t>
+              <a:t>4/21/2026</a:t>
             </a:fld>
             <a:endParaRPr lang="en-US"/>
           </a:p>
@@ -3450,6 +3451,36 @@
 </p:sld>
 </file>
 
+<file path=ppt/slides/slide2.xml><?xml version="1.0" encoding="utf-8"?>
+<p:sld xmlns:a="http://schemas.openxmlformats.org/drawingml/2006/main" xmlns:r="http://schemas.openxmlformats.org/officeDocument/2006/relationships" xmlns:p="http://schemas.openxmlformats.org/presentationml/2006/main">
+  <p:cSld>
+    <p:spTree>
+      <p:nvGrpSpPr>
+        <p:cNvPr id="1" name=""/>
+        <p:cNvGrpSpPr/>
+        <p:nvPr/>
+      </p:nvGrpSpPr>
+      <p:grpSpPr>
+        <a:xfrm>
+          <a:off x="0" y="0"/>
+          <a:ext cx="0" cy="0"/>
+          <a:chOff x="0" y="0"/>
+          <a:chExt cx="0" cy="0"/>
+        </a:xfrm>
+      </p:grpSpPr>
+    </p:spTree>
+    <p:extLst>
+      <p:ext uri="{BB962C8B-B14F-4D97-AF65-F5344CB8AC3E}">
+        <p14:creationId xmlns:p14="http://schemas.microsoft.com/office/powerpoint/2010/main" val="3505005788"/>
+      </p:ext>
+    </p:extLst>
+  </p:cSld>
+  <p:clrMapOvr>
+    <a:masterClrMapping/>
+  </p:clrMapOvr>
+</p:sld>
+</file>
+
 <file path=ppt/theme/theme1.xml><?xml version="1.0" encoding="utf-8"?>
 <a:theme xmlns:a="http://schemas.openxmlformats.org/drawingml/2006/main" name="Office Theme">
   <a:themeElements>

</xml_diff>

<commit_message>
added wolf kill available plots
</commit_message>
<xml_diff>
--- a/figures/edit_plots.pptx
+++ b/figures/edit_plots.pptx
@@ -6,6 +6,7 @@
   </p:sldMasterIdLst>
   <p:sldIdLst>
     <p:sldId id="256" r:id="rId2"/>
+    <p:sldId id="257" r:id="rId3"/>
   </p:sldIdLst>
   <p:sldSz cx="12192000" cy="6858000"/>
   <p:notesSz cx="6858000" cy="9144000"/>
@@ -259,7 +260,7 @@
           <a:p>
             <a:fld id="{D5E57551-51E6-461E-8289-1C3752ED2C25}" type="datetimeFigureOut">
               <a:rPr lang="en-US" smtClean="0"/>
-              <a:t>4/18/2026</a:t>
+              <a:t>4/21/2026</a:t>
             </a:fld>
             <a:endParaRPr lang="en-US"/>
           </a:p>
@@ -457,7 +458,7 @@
           <a:p>
             <a:fld id="{D5E57551-51E6-461E-8289-1C3752ED2C25}" type="datetimeFigureOut">
               <a:rPr lang="en-US" smtClean="0"/>
-              <a:t>4/18/2026</a:t>
+              <a:t>4/21/2026</a:t>
             </a:fld>
             <a:endParaRPr lang="en-US"/>
           </a:p>
@@ -665,7 +666,7 @@
           <a:p>
             <a:fld id="{D5E57551-51E6-461E-8289-1C3752ED2C25}" type="datetimeFigureOut">
               <a:rPr lang="en-US" smtClean="0"/>
-              <a:t>4/18/2026</a:t>
+              <a:t>4/21/2026</a:t>
             </a:fld>
             <a:endParaRPr lang="en-US"/>
           </a:p>
@@ -863,7 +864,7 @@
           <a:p>
             <a:fld id="{D5E57551-51E6-461E-8289-1C3752ED2C25}" type="datetimeFigureOut">
               <a:rPr lang="en-US" smtClean="0"/>
-              <a:t>4/18/2026</a:t>
+              <a:t>4/21/2026</a:t>
             </a:fld>
             <a:endParaRPr lang="en-US"/>
           </a:p>
@@ -1138,7 +1139,7 @@
           <a:p>
             <a:fld id="{D5E57551-51E6-461E-8289-1C3752ED2C25}" type="datetimeFigureOut">
               <a:rPr lang="en-US" smtClean="0"/>
-              <a:t>4/18/2026</a:t>
+              <a:t>4/21/2026</a:t>
             </a:fld>
             <a:endParaRPr lang="en-US"/>
           </a:p>
@@ -1403,7 +1404,7 @@
           <a:p>
             <a:fld id="{D5E57551-51E6-461E-8289-1C3752ED2C25}" type="datetimeFigureOut">
               <a:rPr lang="en-US" smtClean="0"/>
-              <a:t>4/18/2026</a:t>
+              <a:t>4/21/2026</a:t>
             </a:fld>
             <a:endParaRPr lang="en-US"/>
           </a:p>
@@ -1815,7 +1816,7 @@
           <a:p>
             <a:fld id="{D5E57551-51E6-461E-8289-1C3752ED2C25}" type="datetimeFigureOut">
               <a:rPr lang="en-US" smtClean="0"/>
-              <a:t>4/18/2026</a:t>
+              <a:t>4/21/2026</a:t>
             </a:fld>
             <a:endParaRPr lang="en-US"/>
           </a:p>
@@ -1956,7 +1957,7 @@
           <a:p>
             <a:fld id="{D5E57551-51E6-461E-8289-1C3752ED2C25}" type="datetimeFigureOut">
               <a:rPr lang="en-US" smtClean="0"/>
-              <a:t>4/18/2026</a:t>
+              <a:t>4/21/2026</a:t>
             </a:fld>
             <a:endParaRPr lang="en-US"/>
           </a:p>
@@ -2069,7 +2070,7 @@
           <a:p>
             <a:fld id="{D5E57551-51E6-461E-8289-1C3752ED2C25}" type="datetimeFigureOut">
               <a:rPr lang="en-US" smtClean="0"/>
-              <a:t>4/18/2026</a:t>
+              <a:t>4/21/2026</a:t>
             </a:fld>
             <a:endParaRPr lang="en-US"/>
           </a:p>
@@ -2380,7 +2381,7 @@
           <a:p>
             <a:fld id="{D5E57551-51E6-461E-8289-1C3752ED2C25}" type="datetimeFigureOut">
               <a:rPr lang="en-US" smtClean="0"/>
-              <a:t>4/18/2026</a:t>
+              <a:t>4/21/2026</a:t>
             </a:fld>
             <a:endParaRPr lang="en-US"/>
           </a:p>
@@ -2668,7 +2669,7 @@
           <a:p>
             <a:fld id="{D5E57551-51E6-461E-8289-1C3752ED2C25}" type="datetimeFigureOut">
               <a:rPr lang="en-US" smtClean="0"/>
-              <a:t>4/18/2026</a:t>
+              <a:t>4/21/2026</a:t>
             </a:fld>
             <a:endParaRPr lang="en-US"/>
           </a:p>
@@ -2909,7 +2910,7 @@
           <a:p>
             <a:fld id="{D5E57551-51E6-461E-8289-1C3752ED2C25}" type="datetimeFigureOut">
               <a:rPr lang="en-US" smtClean="0"/>
-              <a:t>4/18/2026</a:t>
+              <a:t>4/21/2026</a:t>
             </a:fld>
             <a:endParaRPr lang="en-US"/>
           </a:p>
@@ -3450,6 +3451,36 @@
 </p:sld>
 </file>
 
+<file path=ppt/slides/slide2.xml><?xml version="1.0" encoding="utf-8"?>
+<p:sld xmlns:a="http://schemas.openxmlformats.org/drawingml/2006/main" xmlns:r="http://schemas.openxmlformats.org/officeDocument/2006/relationships" xmlns:p="http://schemas.openxmlformats.org/presentationml/2006/main">
+  <p:cSld>
+    <p:spTree>
+      <p:nvGrpSpPr>
+        <p:cNvPr id="1" name=""/>
+        <p:cNvGrpSpPr/>
+        <p:nvPr/>
+      </p:nvGrpSpPr>
+      <p:grpSpPr>
+        <a:xfrm>
+          <a:off x="0" y="0"/>
+          <a:ext cx="0" cy="0"/>
+          <a:chOff x="0" y="0"/>
+          <a:chExt cx="0" cy="0"/>
+        </a:xfrm>
+      </p:grpSpPr>
+    </p:spTree>
+    <p:extLst>
+      <p:ext uri="{BB962C8B-B14F-4D97-AF65-F5344CB8AC3E}">
+        <p14:creationId xmlns:p14="http://schemas.microsoft.com/office/powerpoint/2010/main" val="3505005788"/>
+      </p:ext>
+    </p:extLst>
+  </p:cSld>
+  <p:clrMapOvr>
+    <a:masterClrMapping/>
+  </p:clrMapOvr>
+</p:sld>
+</file>
+
 <file path=ppt/theme/theme1.xml><?xml version="1.0" encoding="utf-8"?>
 <a:theme xmlns:a="http://schemas.openxmlformats.org/drawingml/2006/main" name="Office Theme">
   <a:themeElements>

</xml_diff>